<commit_message>
Add instrument light icons and elevator trim icons
</commit_message>
<xml_diff>
--- a/StreamDeck/icons/icons.pptx
+++ b/StreamDeck/icons/icons.pptx
@@ -7,6 +7,7 @@
   <p:sldIdLst>
     <p:sldId id="256" r:id="rId2"/>
     <p:sldId id="257" r:id="rId3"/>
+    <p:sldId id="258" r:id="rId4"/>
   </p:sldIdLst>
   <p:sldSz cx="12192000" cy="6858000"/>
   <p:notesSz cx="6858000" cy="9144000"/>
@@ -260,7 +261,7 @@
           <a:p>
             <a:fld id="{3FA526AB-D1C4-5D45-B2AC-D6A1C568BB3B}" type="datetimeFigureOut">
               <a:rPr lang="en-US" smtClean="0"/>
-              <a:t>2/25/26</a:t>
+              <a:t>2/26/26</a:t>
             </a:fld>
             <a:endParaRPr lang="en-US"/>
           </a:p>
@@ -458,7 +459,7 @@
           <a:p>
             <a:fld id="{3FA526AB-D1C4-5D45-B2AC-D6A1C568BB3B}" type="datetimeFigureOut">
               <a:rPr lang="en-US" smtClean="0"/>
-              <a:t>2/25/26</a:t>
+              <a:t>2/26/26</a:t>
             </a:fld>
             <a:endParaRPr lang="en-US"/>
           </a:p>
@@ -666,7 +667,7 @@
           <a:p>
             <a:fld id="{3FA526AB-D1C4-5D45-B2AC-D6A1C568BB3B}" type="datetimeFigureOut">
               <a:rPr lang="en-US" smtClean="0"/>
-              <a:t>2/25/26</a:t>
+              <a:t>2/26/26</a:t>
             </a:fld>
             <a:endParaRPr lang="en-US"/>
           </a:p>
@@ -864,7 +865,7 @@
           <a:p>
             <a:fld id="{3FA526AB-D1C4-5D45-B2AC-D6A1C568BB3B}" type="datetimeFigureOut">
               <a:rPr lang="en-US" smtClean="0"/>
-              <a:t>2/25/26</a:t>
+              <a:t>2/26/26</a:t>
             </a:fld>
             <a:endParaRPr lang="en-US"/>
           </a:p>
@@ -1139,7 +1140,7 @@
           <a:p>
             <a:fld id="{3FA526AB-D1C4-5D45-B2AC-D6A1C568BB3B}" type="datetimeFigureOut">
               <a:rPr lang="en-US" smtClean="0"/>
-              <a:t>2/25/26</a:t>
+              <a:t>2/26/26</a:t>
             </a:fld>
             <a:endParaRPr lang="en-US"/>
           </a:p>
@@ -1404,7 +1405,7 @@
           <a:p>
             <a:fld id="{3FA526AB-D1C4-5D45-B2AC-D6A1C568BB3B}" type="datetimeFigureOut">
               <a:rPr lang="en-US" smtClean="0"/>
-              <a:t>2/25/26</a:t>
+              <a:t>2/26/26</a:t>
             </a:fld>
             <a:endParaRPr lang="en-US"/>
           </a:p>
@@ -1816,7 +1817,7 @@
           <a:p>
             <a:fld id="{3FA526AB-D1C4-5D45-B2AC-D6A1C568BB3B}" type="datetimeFigureOut">
               <a:rPr lang="en-US" smtClean="0"/>
-              <a:t>2/25/26</a:t>
+              <a:t>2/26/26</a:t>
             </a:fld>
             <a:endParaRPr lang="en-US"/>
           </a:p>
@@ -1957,7 +1958,7 @@
           <a:p>
             <a:fld id="{3FA526AB-D1C4-5D45-B2AC-D6A1C568BB3B}" type="datetimeFigureOut">
               <a:rPr lang="en-US" smtClean="0"/>
-              <a:t>2/25/26</a:t>
+              <a:t>2/26/26</a:t>
             </a:fld>
             <a:endParaRPr lang="en-US"/>
           </a:p>
@@ -2070,7 +2071,7 @@
           <a:p>
             <a:fld id="{3FA526AB-D1C4-5D45-B2AC-D6A1C568BB3B}" type="datetimeFigureOut">
               <a:rPr lang="en-US" smtClean="0"/>
-              <a:t>2/25/26</a:t>
+              <a:t>2/26/26</a:t>
             </a:fld>
             <a:endParaRPr lang="en-US"/>
           </a:p>
@@ -2381,7 +2382,7 @@
           <a:p>
             <a:fld id="{3FA526AB-D1C4-5D45-B2AC-D6A1C568BB3B}" type="datetimeFigureOut">
               <a:rPr lang="en-US" smtClean="0"/>
-              <a:t>2/25/26</a:t>
+              <a:t>2/26/26</a:t>
             </a:fld>
             <a:endParaRPr lang="en-US"/>
           </a:p>
@@ -2669,7 +2670,7 @@
           <a:p>
             <a:fld id="{3FA526AB-D1C4-5D45-B2AC-D6A1C568BB3B}" type="datetimeFigureOut">
               <a:rPr lang="en-US" smtClean="0"/>
-              <a:t>2/25/26</a:t>
+              <a:t>2/26/26</a:t>
             </a:fld>
             <a:endParaRPr lang="en-US"/>
           </a:p>
@@ -2910,7 +2911,7 @@
           <a:p>
             <a:fld id="{3FA526AB-D1C4-5D45-B2AC-D6A1C568BB3B}" type="datetimeFigureOut">
               <a:rPr lang="en-US" smtClean="0"/>
-              <a:t>2/25/26</a:t>
+              <a:t>2/26/26</a:t>
             </a:fld>
             <a:endParaRPr lang="en-US"/>
           </a:p>
@@ -3349,7 +3350,7 @@
         </p:blipFill>
         <p:spPr>
           <a:xfrm>
-            <a:off x="4540250" y="1859703"/>
+            <a:off x="585170" y="223138"/>
             <a:ext cx="3111500" cy="3111500"/>
           </a:xfrm>
           <a:prstGeom prst="rect">
@@ -3357,12 +3358,42 @@
           </a:prstGeom>
         </p:spPr>
       </p:pic>
-      <p:sp>
-        <p:nvSpPr>
-          <p:cNvPr id="7" name="Down Arrow 6">
-            <a:extLst>
-              <a:ext uri="{FF2B5EF4-FFF2-40B4-BE49-F238E27FC236}">
-                <a16:creationId xmlns:a16="http://schemas.microsoft.com/office/drawing/2014/main" id="{A8729AFE-1834-E36A-0114-461A28BBB265}"/>
+      <p:pic>
+        <p:nvPicPr>
+          <p:cNvPr id="2" name="Picture 1" descr="A black and white image of a long black and white animal&#10;&#10;AI-generated content may be incorrect.">
+            <a:extLst>
+              <a:ext uri="{FF2B5EF4-FFF2-40B4-BE49-F238E27FC236}">
+                <a16:creationId xmlns:a16="http://schemas.microsoft.com/office/drawing/2014/main" id="{61E99B7F-2F10-2D40-C691-7AB55E1CB618}"/>
+              </a:ext>
+            </a:extLst>
+          </p:cNvPr>
+          <p:cNvPicPr>
+            <a:picLocks noChangeAspect="1"/>
+          </p:cNvPicPr>
+          <p:nvPr/>
+        </p:nvPicPr>
+        <p:blipFill>
+          <a:blip r:embed="rId2"/>
+          <a:stretch>
+            <a:fillRect/>
+          </a:stretch>
+        </p:blipFill>
+        <p:spPr>
+          <a:xfrm>
+            <a:off x="5269045" y="440896"/>
+            <a:ext cx="4313098" cy="6157992"/>
+          </a:xfrm>
+          <a:prstGeom prst="rect">
+            <a:avLst/>
+          </a:prstGeom>
+        </p:spPr>
+      </p:pic>
+      <p:sp>
+        <p:nvSpPr>
+          <p:cNvPr id="3" name="Down Arrow 2">
+            <a:extLst>
+              <a:ext uri="{FF2B5EF4-FFF2-40B4-BE49-F238E27FC236}">
+                <a16:creationId xmlns:a16="http://schemas.microsoft.com/office/drawing/2014/main" id="{A9B70641-340C-47A9-5F29-69C74FDD9D6D}"/>
               </a:ext>
             </a:extLst>
           </p:cNvPr>
@@ -3371,8 +3402,8 @@
         </p:nvSpPr>
         <p:spPr>
           <a:xfrm>
-            <a:off x="7065220" y="3376506"/>
-            <a:ext cx="138220" cy="137624"/>
+            <a:off x="8545640" y="3334637"/>
+            <a:ext cx="155908" cy="192439"/>
           </a:xfrm>
           <a:prstGeom prst="downArrow">
             <a:avLst/>
@@ -3380,6 +3411,11 @@
           <a:solidFill>
             <a:schemeClr val="tx1"/>
           </a:solidFill>
+          <a:ln>
+            <a:solidFill>
+              <a:schemeClr val="tx1"/>
+            </a:solidFill>
+          </a:ln>
         </p:spPr>
         <p:style>
           <a:lnRef idx="2">
@@ -3408,10 +3444,10 @@
       </p:sp>
       <p:sp>
         <p:nvSpPr>
-          <p:cNvPr id="8" name="Rectangle 7">
-            <a:extLst>
-              <a:ext uri="{FF2B5EF4-FFF2-40B4-BE49-F238E27FC236}">
-                <a16:creationId xmlns:a16="http://schemas.microsoft.com/office/drawing/2014/main" id="{3AA446C2-7656-05F2-6726-02069CDBCD6B}"/>
+          <p:cNvPr id="13" name="Rectangle 12">
+            <a:extLst>
+              <a:ext uri="{FF2B5EF4-FFF2-40B4-BE49-F238E27FC236}">
+                <a16:creationId xmlns:a16="http://schemas.microsoft.com/office/drawing/2014/main" id="{3F36CD09-B230-3F83-7F3D-AE0F406C2753}"/>
               </a:ext>
             </a:extLst>
           </p:cNvPr>
@@ -3420,8 +3456,8 @@
         </p:nvSpPr>
         <p:spPr>
           <a:xfrm>
-            <a:off x="7098453" y="3283374"/>
-            <a:ext cx="67734" cy="45719"/>
+            <a:off x="8583740" y="3208620"/>
+            <a:ext cx="80835" cy="45719"/>
           </a:xfrm>
           <a:prstGeom prst="rect">
             <a:avLst/>
@@ -3429,6 +3465,11 @@
           <a:solidFill>
             <a:schemeClr val="tx1"/>
           </a:solidFill>
+          <a:ln>
+            <a:solidFill>
+              <a:schemeClr val="tx1"/>
+            </a:solidFill>
+          </a:ln>
         </p:spPr>
         <p:style>
           <a:lnRef idx="2">
@@ -3457,10 +3498,10 @@
       </p:sp>
       <p:sp>
         <p:nvSpPr>
-          <p:cNvPr id="9" name="Rectangle 8">
-            <a:extLst>
-              <a:ext uri="{FF2B5EF4-FFF2-40B4-BE49-F238E27FC236}">
-                <a16:creationId xmlns:a16="http://schemas.microsoft.com/office/drawing/2014/main" id="{4B43F26E-5F1C-D13B-13E0-425F5A21614D}"/>
+          <p:cNvPr id="4" name="Rectangle 3">
+            <a:extLst>
+              <a:ext uri="{FF2B5EF4-FFF2-40B4-BE49-F238E27FC236}">
+                <a16:creationId xmlns:a16="http://schemas.microsoft.com/office/drawing/2014/main" id="{4B5F59D7-3743-DD15-4233-23C4DCAB17AE}"/>
               </a:ext>
             </a:extLst>
           </p:cNvPr>
@@ -3469,8 +3510,8 @@
         </p:nvSpPr>
         <p:spPr>
           <a:xfrm>
-            <a:off x="7098453" y="3190242"/>
-            <a:ext cx="67734" cy="45719"/>
+            <a:off x="8583176" y="3082603"/>
+            <a:ext cx="80835" cy="45719"/>
           </a:xfrm>
           <a:prstGeom prst="rect">
             <a:avLst/>
@@ -3478,6 +3519,11 @@
           <a:solidFill>
             <a:schemeClr val="tx1"/>
           </a:solidFill>
+          <a:ln>
+            <a:solidFill>
+              <a:schemeClr val="tx1"/>
+            </a:solidFill>
+          </a:ln>
         </p:spPr>
         <p:style>
           <a:lnRef idx="2">
@@ -3506,10 +3552,10 @@
       </p:sp>
       <p:sp>
         <p:nvSpPr>
-          <p:cNvPr id="10" name="Rectangle 9">
-            <a:extLst>
-              <a:ext uri="{FF2B5EF4-FFF2-40B4-BE49-F238E27FC236}">
-                <a16:creationId xmlns:a16="http://schemas.microsoft.com/office/drawing/2014/main" id="{57B52523-B73C-3877-9C80-C8D2BDA92F2F}"/>
+          <p:cNvPr id="6" name="Rectangle 5">
+            <a:extLst>
+              <a:ext uri="{FF2B5EF4-FFF2-40B4-BE49-F238E27FC236}">
+                <a16:creationId xmlns:a16="http://schemas.microsoft.com/office/drawing/2014/main" id="{7372E6EE-BE8F-0387-AFEB-61093BC132DE}"/>
               </a:ext>
             </a:extLst>
           </p:cNvPr>
@@ -3518,8 +3564,8 @@
         </p:nvSpPr>
         <p:spPr>
           <a:xfrm>
-            <a:off x="7098453" y="3097110"/>
-            <a:ext cx="67734" cy="45719"/>
+            <a:off x="8583176" y="2956586"/>
+            <a:ext cx="80835" cy="45719"/>
           </a:xfrm>
           <a:prstGeom prst="rect">
             <a:avLst/>
@@ -3527,6 +3573,11 @@
           <a:solidFill>
             <a:schemeClr val="tx1"/>
           </a:solidFill>
+          <a:ln>
+            <a:solidFill>
+              <a:schemeClr val="tx1"/>
+            </a:solidFill>
+          </a:ln>
         </p:spPr>
         <p:style>
           <a:lnRef idx="2">
@@ -3919,6 +3970,216 @@
     <p:extLst>
       <p:ext uri="{BB962C8B-B14F-4D97-AF65-F5344CB8AC3E}">
         <p14:creationId xmlns:p14="http://schemas.microsoft.com/office/powerpoint/2010/main" val="1745080395"/>
+      </p:ext>
+    </p:extLst>
+  </p:cSld>
+  <p:clrMapOvr>
+    <a:masterClrMapping/>
+  </p:clrMapOvr>
+</p:sld>
+</file>
+
+<file path=ppt/slides/slide3.xml><?xml version="1.0" encoding="utf-8"?>
+<p:sld xmlns:a="http://schemas.openxmlformats.org/drawingml/2006/main" xmlns:r="http://schemas.openxmlformats.org/officeDocument/2006/relationships" xmlns:p="http://schemas.openxmlformats.org/presentationml/2006/main">
+  <p:cSld>
+    <p:spTree>
+      <p:nvGrpSpPr>
+        <p:cNvPr id="1" name=""/>
+        <p:cNvGrpSpPr/>
+        <p:nvPr/>
+      </p:nvGrpSpPr>
+      <p:grpSpPr>
+        <a:xfrm>
+          <a:off x="0" y="0"/>
+          <a:ext cx="0" cy="0"/>
+          <a:chOff x="0" y="0"/>
+          <a:chExt cx="0" cy="0"/>
+        </a:xfrm>
+      </p:grpSpPr>
+      <p:sp>
+        <p:nvSpPr>
+          <p:cNvPr id="6" name="Rectangle 5">
+            <a:extLst>
+              <a:ext uri="{FF2B5EF4-FFF2-40B4-BE49-F238E27FC236}">
+                <a16:creationId xmlns:a16="http://schemas.microsoft.com/office/drawing/2014/main" id="{5F9EF3E3-D6F1-D94E-65D6-92353700A233}"/>
+              </a:ext>
+            </a:extLst>
+          </p:cNvPr>
+          <p:cNvSpPr/>
+          <p:nvPr/>
+        </p:nvSpPr>
+        <p:spPr>
+          <a:xfrm>
+            <a:off x="2041754" y="2081621"/>
+            <a:ext cx="2363209" cy="2363209"/>
+          </a:xfrm>
+          <a:prstGeom prst="rect">
+            <a:avLst/>
+          </a:prstGeom>
+          <a:solidFill>
+            <a:schemeClr val="tx1"/>
+          </a:solidFill>
+          <a:ln>
+            <a:solidFill>
+              <a:schemeClr val="tx1"/>
+            </a:solidFill>
+          </a:ln>
+        </p:spPr>
+        <p:style>
+          <a:lnRef idx="2">
+            <a:schemeClr val="accent1">
+              <a:shade val="15000"/>
+            </a:schemeClr>
+          </a:lnRef>
+          <a:fillRef idx="1">
+            <a:schemeClr val="accent1"/>
+          </a:fillRef>
+          <a:effectRef idx="0">
+            <a:schemeClr val="accent1"/>
+          </a:effectRef>
+          <a:fontRef idx="minor">
+            <a:schemeClr val="lt1"/>
+          </a:fontRef>
+        </p:style>
+        <p:txBody>
+          <a:bodyPr rtlCol="0" anchor="ctr"/>
+          <a:lstStyle/>
+          <a:p>
+            <a:pPr algn="ctr"/>
+            <a:endParaRPr lang="en-US"/>
+          </a:p>
+        </p:txBody>
+      </p:sp>
+      <p:pic>
+        <p:nvPicPr>
+          <p:cNvPr id="5" name="Graphic 4" descr="Gauge with solid fill">
+            <a:extLst>
+              <a:ext uri="{FF2B5EF4-FFF2-40B4-BE49-F238E27FC236}">
+                <a16:creationId xmlns:a16="http://schemas.microsoft.com/office/drawing/2014/main" id="{87365805-590C-8FC0-C486-853D4F18ABF5}"/>
+              </a:ext>
+            </a:extLst>
+          </p:cNvPr>
+          <p:cNvPicPr>
+            <a:picLocks noChangeAspect="1"/>
+          </p:cNvPicPr>
+          <p:nvPr/>
+        </p:nvPicPr>
+        <p:blipFill>
+          <a:blip r:embed="rId2">
+            <a:extLst>
+              <a:ext uri="{96DAC541-7B7A-43D3-8B79-37D633B846F1}">
+                <asvg:svgBlip xmlns:asvg="http://schemas.microsoft.com/office/drawing/2016/SVG/main" r:embed="rId3"/>
+              </a:ext>
+            </a:extLst>
+          </a:blip>
+          <a:stretch>
+            <a:fillRect/>
+          </a:stretch>
+        </p:blipFill>
+        <p:spPr>
+          <a:xfrm>
+            <a:off x="2041755" y="2081622"/>
+            <a:ext cx="2363209" cy="2363209"/>
+          </a:xfrm>
+          <a:prstGeom prst="rect">
+            <a:avLst/>
+          </a:prstGeom>
+        </p:spPr>
+      </p:pic>
+      <p:sp>
+        <p:nvSpPr>
+          <p:cNvPr id="7" name="Rectangle 6">
+            <a:extLst>
+              <a:ext uri="{FF2B5EF4-FFF2-40B4-BE49-F238E27FC236}">
+                <a16:creationId xmlns:a16="http://schemas.microsoft.com/office/drawing/2014/main" id="{8BBB36B0-E585-D3C3-AA85-27C0775A76AD}"/>
+              </a:ext>
+            </a:extLst>
+          </p:cNvPr>
+          <p:cNvSpPr/>
+          <p:nvPr/>
+        </p:nvSpPr>
+        <p:spPr>
+          <a:xfrm>
+            <a:off x="5888088" y="2081621"/>
+            <a:ext cx="2363209" cy="2363209"/>
+          </a:xfrm>
+          <a:prstGeom prst="rect">
+            <a:avLst/>
+          </a:prstGeom>
+          <a:solidFill>
+            <a:schemeClr val="tx1"/>
+          </a:solidFill>
+          <a:ln>
+            <a:solidFill>
+              <a:schemeClr val="tx1"/>
+            </a:solidFill>
+          </a:ln>
+        </p:spPr>
+        <p:style>
+          <a:lnRef idx="2">
+            <a:schemeClr val="accent1">
+              <a:shade val="15000"/>
+            </a:schemeClr>
+          </a:lnRef>
+          <a:fillRef idx="1">
+            <a:schemeClr val="accent1"/>
+          </a:fillRef>
+          <a:effectRef idx="0">
+            <a:schemeClr val="accent1"/>
+          </a:effectRef>
+          <a:fontRef idx="minor">
+            <a:schemeClr val="lt1"/>
+          </a:fontRef>
+        </p:style>
+        <p:txBody>
+          <a:bodyPr rtlCol="0" anchor="ctr"/>
+          <a:lstStyle/>
+          <a:p>
+            <a:pPr algn="ctr"/>
+            <a:endParaRPr lang="en-US"/>
+          </a:p>
+        </p:txBody>
+      </p:sp>
+      <p:pic>
+        <p:nvPicPr>
+          <p:cNvPr id="8" name="Graphic 7" descr="Gauge with solid fill">
+            <a:extLst>
+              <a:ext uri="{FF2B5EF4-FFF2-40B4-BE49-F238E27FC236}">
+                <a16:creationId xmlns:a16="http://schemas.microsoft.com/office/drawing/2014/main" id="{87A017EC-FA8E-5B79-2EA1-1115A9C4F2EB}"/>
+              </a:ext>
+            </a:extLst>
+          </p:cNvPr>
+          <p:cNvPicPr>
+            <a:picLocks noChangeAspect="1"/>
+          </p:cNvPicPr>
+          <p:nvPr/>
+        </p:nvPicPr>
+        <p:blipFill>
+          <a:blip r:embed="rId4">
+            <a:extLst>
+              <a:ext uri="{96DAC541-7B7A-43D3-8B79-37D633B846F1}">
+                <asvg:svgBlip xmlns:asvg="http://schemas.microsoft.com/office/drawing/2016/SVG/main" r:embed="rId5"/>
+              </a:ext>
+            </a:extLst>
+          </a:blip>
+          <a:stretch>
+            <a:fillRect/>
+          </a:stretch>
+        </p:blipFill>
+        <p:spPr>
+          <a:xfrm>
+            <a:off x="5888089" y="2081622"/>
+            <a:ext cx="2363209" cy="2363209"/>
+          </a:xfrm>
+          <a:prstGeom prst="rect">
+            <a:avLst/>
+          </a:prstGeom>
+        </p:spPr>
+      </p:pic>
+    </p:spTree>
+    <p:extLst>
+      <p:ext uri="{BB962C8B-B14F-4D97-AF65-F5344CB8AC3E}">
+        <p14:creationId xmlns:p14="http://schemas.microsoft.com/office/powerpoint/2010/main" val="3806950538"/>
       </p:ext>
     </p:extLst>
   </p:cSld>

</xml_diff>

<commit_message>
update trim icons so arrow looks better
</commit_message>
<xml_diff>
--- a/StreamDeck/icons/icons.pptx
+++ b/StreamDeck/icons/icons.pptx
@@ -3402,8 +3402,8 @@
         </p:nvSpPr>
         <p:spPr>
           <a:xfrm>
-            <a:off x="8545640" y="3334637"/>
-            <a:ext cx="155908" cy="192439"/>
+            <a:off x="8545639" y="3151909"/>
+            <a:ext cx="342051" cy="375167"/>
           </a:xfrm>
           <a:prstGeom prst="downArrow">
             <a:avLst/>
@@ -3444,10 +3444,10 @@
       </p:sp>
       <p:sp>
         <p:nvSpPr>
-          <p:cNvPr id="13" name="Rectangle 12">
-            <a:extLst>
-              <a:ext uri="{FF2B5EF4-FFF2-40B4-BE49-F238E27FC236}">
-                <a16:creationId xmlns:a16="http://schemas.microsoft.com/office/drawing/2014/main" id="{3F36CD09-B230-3F83-7F3D-AE0F406C2753}"/>
+          <p:cNvPr id="6" name="Rectangle 5">
+            <a:extLst>
+              <a:ext uri="{FF2B5EF4-FFF2-40B4-BE49-F238E27FC236}">
+                <a16:creationId xmlns:a16="http://schemas.microsoft.com/office/drawing/2014/main" id="{7372E6EE-BE8F-0387-AFEB-61093BC132DE}"/>
               </a:ext>
             </a:extLst>
           </p:cNvPr>
@@ -3455,9 +3455,9 @@
           <p:nvPr/>
         </p:nvSpPr>
         <p:spPr>
-          <a:xfrm>
-            <a:off x="8583740" y="3208620"/>
-            <a:ext cx="80835" cy="45719"/>
+          <a:xfrm flipH="1" flipV="1">
+            <a:off x="8635692" y="2937163"/>
+            <a:ext cx="161944" cy="117787"/>
           </a:xfrm>
           <a:prstGeom prst="rect">
             <a:avLst/>
@@ -3498,10 +3498,10 @@
       </p:sp>
       <p:sp>
         <p:nvSpPr>
-          <p:cNvPr id="4" name="Rectangle 3">
-            <a:extLst>
-              <a:ext uri="{FF2B5EF4-FFF2-40B4-BE49-F238E27FC236}">
-                <a16:creationId xmlns:a16="http://schemas.microsoft.com/office/drawing/2014/main" id="{4B5F59D7-3743-DD15-4233-23C4DCAB17AE}"/>
+          <p:cNvPr id="7" name="Rectangle 6">
+            <a:extLst>
+              <a:ext uri="{FF2B5EF4-FFF2-40B4-BE49-F238E27FC236}">
+                <a16:creationId xmlns:a16="http://schemas.microsoft.com/office/drawing/2014/main" id="{80F4CBA0-1ABF-87E1-16AF-F18AF33A8A60}"/>
               </a:ext>
             </a:extLst>
           </p:cNvPr>
@@ -3509,9 +3509,9 @@
           <p:nvPr/>
         </p:nvSpPr>
         <p:spPr>
-          <a:xfrm>
-            <a:off x="8583176" y="3082603"/>
-            <a:ext cx="80835" cy="45719"/>
+          <a:xfrm flipH="1" flipV="1">
+            <a:off x="8635692" y="2722417"/>
+            <a:ext cx="161944" cy="117787"/>
           </a:xfrm>
           <a:prstGeom prst="rect">
             <a:avLst/>
@@ -3552,10 +3552,10 @@
       </p:sp>
       <p:sp>
         <p:nvSpPr>
-          <p:cNvPr id="6" name="Rectangle 5">
-            <a:extLst>
-              <a:ext uri="{FF2B5EF4-FFF2-40B4-BE49-F238E27FC236}">
-                <a16:creationId xmlns:a16="http://schemas.microsoft.com/office/drawing/2014/main" id="{7372E6EE-BE8F-0387-AFEB-61093BC132DE}"/>
+          <p:cNvPr id="8" name="Rectangle 7">
+            <a:extLst>
+              <a:ext uri="{FF2B5EF4-FFF2-40B4-BE49-F238E27FC236}">
+                <a16:creationId xmlns:a16="http://schemas.microsoft.com/office/drawing/2014/main" id="{B8CCCC30-8E29-117A-60F2-9B21C026A953}"/>
               </a:ext>
             </a:extLst>
           </p:cNvPr>
@@ -3563,9 +3563,9 @@
           <p:nvPr/>
         </p:nvSpPr>
         <p:spPr>
-          <a:xfrm>
-            <a:off x="8583176" y="2956586"/>
-            <a:ext cx="80835" cy="45719"/>
+          <a:xfrm flipH="1" flipV="1">
+            <a:off x="8635692" y="2497257"/>
+            <a:ext cx="161944" cy="117787"/>
           </a:xfrm>
           <a:prstGeom prst="rect">
             <a:avLst/>

</xml_diff>

<commit_message>
add plus and minus icons
</commit_message>
<xml_diff>
--- a/StreamDeck/icons/icons.pptx
+++ b/StreamDeck/icons/icons.pptx
@@ -9,6 +9,10 @@
     <p:sldId id="257" r:id="rId3"/>
     <p:sldId id="258" r:id="rId4"/>
     <p:sldId id="259" r:id="rId5"/>
+    <p:sldId id="260" r:id="rId6"/>
+    <p:sldId id="261" r:id="rId7"/>
+    <p:sldId id="262" r:id="rId8"/>
+    <p:sldId id="263" r:id="rId9"/>
   </p:sldIdLst>
   <p:sldSz cx="12192000" cy="6858000"/>
   <p:notesSz cx="6858000" cy="9144000"/>
@@ -262,7 +266,7 @@
           <a:p>
             <a:fld id="{3FA526AB-D1C4-5D45-B2AC-D6A1C568BB3B}" type="datetimeFigureOut">
               <a:rPr lang="en-US" smtClean="0"/>
-              <a:t>3/2/26</a:t>
+              <a:t>3/4/26</a:t>
             </a:fld>
             <a:endParaRPr lang="en-US"/>
           </a:p>
@@ -460,7 +464,7 @@
           <a:p>
             <a:fld id="{3FA526AB-D1C4-5D45-B2AC-D6A1C568BB3B}" type="datetimeFigureOut">
               <a:rPr lang="en-US" smtClean="0"/>
-              <a:t>3/2/26</a:t>
+              <a:t>3/4/26</a:t>
             </a:fld>
             <a:endParaRPr lang="en-US"/>
           </a:p>
@@ -668,7 +672,7 @@
           <a:p>
             <a:fld id="{3FA526AB-D1C4-5D45-B2AC-D6A1C568BB3B}" type="datetimeFigureOut">
               <a:rPr lang="en-US" smtClean="0"/>
-              <a:t>3/2/26</a:t>
+              <a:t>3/4/26</a:t>
             </a:fld>
             <a:endParaRPr lang="en-US"/>
           </a:p>
@@ -866,7 +870,7 @@
           <a:p>
             <a:fld id="{3FA526AB-D1C4-5D45-B2AC-D6A1C568BB3B}" type="datetimeFigureOut">
               <a:rPr lang="en-US" smtClean="0"/>
-              <a:t>3/2/26</a:t>
+              <a:t>3/4/26</a:t>
             </a:fld>
             <a:endParaRPr lang="en-US"/>
           </a:p>
@@ -1141,7 +1145,7 @@
           <a:p>
             <a:fld id="{3FA526AB-D1C4-5D45-B2AC-D6A1C568BB3B}" type="datetimeFigureOut">
               <a:rPr lang="en-US" smtClean="0"/>
-              <a:t>3/2/26</a:t>
+              <a:t>3/4/26</a:t>
             </a:fld>
             <a:endParaRPr lang="en-US"/>
           </a:p>
@@ -1406,7 +1410,7 @@
           <a:p>
             <a:fld id="{3FA526AB-D1C4-5D45-B2AC-D6A1C568BB3B}" type="datetimeFigureOut">
               <a:rPr lang="en-US" smtClean="0"/>
-              <a:t>3/2/26</a:t>
+              <a:t>3/4/26</a:t>
             </a:fld>
             <a:endParaRPr lang="en-US"/>
           </a:p>
@@ -1818,7 +1822,7 @@
           <a:p>
             <a:fld id="{3FA526AB-D1C4-5D45-B2AC-D6A1C568BB3B}" type="datetimeFigureOut">
               <a:rPr lang="en-US" smtClean="0"/>
-              <a:t>3/2/26</a:t>
+              <a:t>3/4/26</a:t>
             </a:fld>
             <a:endParaRPr lang="en-US"/>
           </a:p>
@@ -1959,7 +1963,7 @@
           <a:p>
             <a:fld id="{3FA526AB-D1C4-5D45-B2AC-D6A1C568BB3B}" type="datetimeFigureOut">
               <a:rPr lang="en-US" smtClean="0"/>
-              <a:t>3/2/26</a:t>
+              <a:t>3/4/26</a:t>
             </a:fld>
             <a:endParaRPr lang="en-US"/>
           </a:p>
@@ -2072,7 +2076,7 @@
           <a:p>
             <a:fld id="{3FA526AB-D1C4-5D45-B2AC-D6A1C568BB3B}" type="datetimeFigureOut">
               <a:rPr lang="en-US" smtClean="0"/>
-              <a:t>3/2/26</a:t>
+              <a:t>3/4/26</a:t>
             </a:fld>
             <a:endParaRPr lang="en-US"/>
           </a:p>
@@ -2383,7 +2387,7 @@
           <a:p>
             <a:fld id="{3FA526AB-D1C4-5D45-B2AC-D6A1C568BB3B}" type="datetimeFigureOut">
               <a:rPr lang="en-US" smtClean="0"/>
-              <a:t>3/2/26</a:t>
+              <a:t>3/4/26</a:t>
             </a:fld>
             <a:endParaRPr lang="en-US"/>
           </a:p>
@@ -2671,7 +2675,7 @@
           <a:p>
             <a:fld id="{3FA526AB-D1C4-5D45-B2AC-D6A1C568BB3B}" type="datetimeFigureOut">
               <a:rPr lang="en-US" smtClean="0"/>
-              <a:t>3/2/26</a:t>
+              <a:t>3/4/26</a:t>
             </a:fld>
             <a:endParaRPr lang="en-US"/>
           </a:p>
@@ -2912,7 +2916,7 @@
           <a:p>
             <a:fld id="{3FA526AB-D1C4-5D45-B2AC-D6A1C568BB3B}" type="datetimeFigureOut">
               <a:rPr lang="en-US" smtClean="0"/>
-              <a:t>3/2/26</a:t>
+              <a:t>3/4/26</a:t>
             </a:fld>
             <a:endParaRPr lang="en-US"/>
           </a:p>
@@ -4316,6 +4320,810 @@
 </p:sld>
 </file>
 
+<file path=ppt/slides/slide5.xml><?xml version="1.0" encoding="utf-8"?>
+<p:sld xmlns:a="http://schemas.openxmlformats.org/drawingml/2006/main" xmlns:r="http://schemas.openxmlformats.org/officeDocument/2006/relationships" xmlns:p="http://schemas.openxmlformats.org/presentationml/2006/main">
+  <p:cSld>
+    <p:spTree>
+      <p:nvGrpSpPr>
+        <p:cNvPr id="1" name=""/>
+        <p:cNvGrpSpPr/>
+        <p:nvPr/>
+      </p:nvGrpSpPr>
+      <p:grpSpPr>
+        <a:xfrm>
+          <a:off x="0" y="0"/>
+          <a:ext cx="0" cy="0"/>
+          <a:chOff x="0" y="0"/>
+          <a:chExt cx="0" cy="0"/>
+        </a:xfrm>
+      </p:grpSpPr>
+      <p:sp>
+        <p:nvSpPr>
+          <p:cNvPr id="5" name="Rectangle 4">
+            <a:extLst>
+              <a:ext uri="{FF2B5EF4-FFF2-40B4-BE49-F238E27FC236}">
+                <a16:creationId xmlns:a16="http://schemas.microsoft.com/office/drawing/2014/main" id="{BCA5CEC3-21F2-23C5-FFFB-BE2435527658}"/>
+              </a:ext>
+            </a:extLst>
+          </p:cNvPr>
+          <p:cNvSpPr/>
+          <p:nvPr/>
+        </p:nvSpPr>
+        <p:spPr>
+          <a:xfrm>
+            <a:off x="2103120" y="1623060"/>
+            <a:ext cx="1811655" cy="1805940"/>
+          </a:xfrm>
+          <a:prstGeom prst="rect">
+            <a:avLst/>
+          </a:prstGeom>
+          <a:solidFill>
+            <a:schemeClr val="tx1"/>
+          </a:solidFill>
+        </p:spPr>
+        <p:style>
+          <a:lnRef idx="2">
+            <a:schemeClr val="accent1">
+              <a:shade val="15000"/>
+            </a:schemeClr>
+          </a:lnRef>
+          <a:fillRef idx="1">
+            <a:schemeClr val="accent1"/>
+          </a:fillRef>
+          <a:effectRef idx="0">
+            <a:schemeClr val="accent1"/>
+          </a:effectRef>
+          <a:fontRef idx="minor">
+            <a:schemeClr val="lt1"/>
+          </a:fontRef>
+        </p:style>
+        <p:txBody>
+          <a:bodyPr rtlCol="0" anchor="ctr"/>
+          <a:lstStyle/>
+          <a:p>
+            <a:pPr algn="ctr"/>
+            <a:r>
+              <a:rPr lang="en-US" sz="10800" b="1" dirty="0">
+                <a:latin typeface="Arial" panose="020B0604020202020204" pitchFamily="34" charset="0"/>
+                <a:ea typeface="Apple Color Emoji" pitchFamily="2" charset="0"/>
+                <a:cs typeface="Arial" panose="020B0604020202020204" pitchFamily="34" charset="0"/>
+              </a:rPr>
+              <a:t>++</a:t>
+            </a:r>
+          </a:p>
+        </p:txBody>
+      </p:sp>
+    </p:spTree>
+    <p:extLst>
+      <p:ext uri="{BB962C8B-B14F-4D97-AF65-F5344CB8AC3E}">
+        <p14:creationId xmlns:p14="http://schemas.microsoft.com/office/powerpoint/2010/main" val="1408563833"/>
+      </p:ext>
+    </p:extLst>
+  </p:cSld>
+  <p:clrMapOvr>
+    <a:masterClrMapping/>
+  </p:clrMapOvr>
+</p:sld>
+</file>
+
+<file path=ppt/slides/slide6.xml><?xml version="1.0" encoding="utf-8"?>
+<p:sld xmlns:a="http://schemas.openxmlformats.org/drawingml/2006/main" xmlns:r="http://schemas.openxmlformats.org/officeDocument/2006/relationships" xmlns:p="http://schemas.openxmlformats.org/presentationml/2006/main">
+  <p:cSld>
+    <p:spTree>
+      <p:nvGrpSpPr>
+        <p:cNvPr id="1" name="">
+          <a:extLst>
+            <a:ext uri="{FF2B5EF4-FFF2-40B4-BE49-F238E27FC236}">
+              <a16:creationId xmlns:a16="http://schemas.microsoft.com/office/drawing/2014/main" id="{197B63B4-E40A-E4DE-69B2-9B6CD198AC1E}"/>
+            </a:ext>
+          </a:extLst>
+        </p:cNvPr>
+        <p:cNvGrpSpPr/>
+        <p:nvPr/>
+      </p:nvGrpSpPr>
+      <p:grpSpPr>
+        <a:xfrm>
+          <a:off x="0" y="0"/>
+          <a:ext cx="0" cy="0"/>
+          <a:chOff x="0" y="0"/>
+          <a:chExt cx="0" cy="0"/>
+        </a:xfrm>
+      </p:grpSpPr>
+      <p:sp>
+        <p:nvSpPr>
+          <p:cNvPr id="5" name="Rectangle 4">
+            <a:extLst>
+              <a:ext uri="{FF2B5EF4-FFF2-40B4-BE49-F238E27FC236}">
+                <a16:creationId xmlns:a16="http://schemas.microsoft.com/office/drawing/2014/main" id="{B25B8DF1-1BAB-EA43-5583-A00EA7284157}"/>
+              </a:ext>
+            </a:extLst>
+          </p:cNvPr>
+          <p:cNvSpPr/>
+          <p:nvPr/>
+        </p:nvSpPr>
+        <p:spPr>
+          <a:xfrm>
+            <a:off x="2103120" y="1623060"/>
+            <a:ext cx="1811655" cy="1805940"/>
+          </a:xfrm>
+          <a:prstGeom prst="rect">
+            <a:avLst/>
+          </a:prstGeom>
+          <a:solidFill>
+            <a:schemeClr val="tx1"/>
+          </a:solidFill>
+        </p:spPr>
+        <p:style>
+          <a:lnRef idx="2">
+            <a:schemeClr val="accent1">
+              <a:shade val="15000"/>
+            </a:schemeClr>
+          </a:lnRef>
+          <a:fillRef idx="1">
+            <a:schemeClr val="accent1"/>
+          </a:fillRef>
+          <a:effectRef idx="0">
+            <a:schemeClr val="accent1"/>
+          </a:effectRef>
+          <a:fontRef idx="minor">
+            <a:schemeClr val="lt1"/>
+          </a:fontRef>
+        </p:style>
+        <p:txBody>
+          <a:bodyPr rtlCol="0" anchor="ctr"/>
+          <a:lstStyle/>
+          <a:p>
+            <a:pPr algn="ctr"/>
+            <a:r>
+              <a:rPr lang="en-US" sz="10800" b="1" dirty="0">
+                <a:latin typeface="Arial" panose="020B0604020202020204" pitchFamily="34" charset="0"/>
+                <a:ea typeface="Apple Color Emoji" pitchFamily="2" charset="0"/>
+                <a:cs typeface="Arial" panose="020B0604020202020204" pitchFamily="34" charset="0"/>
+              </a:rPr>
+              <a:t>+</a:t>
+            </a:r>
+          </a:p>
+        </p:txBody>
+      </p:sp>
+    </p:spTree>
+    <p:extLst>
+      <p:ext uri="{BB962C8B-B14F-4D97-AF65-F5344CB8AC3E}">
+        <p14:creationId xmlns:p14="http://schemas.microsoft.com/office/powerpoint/2010/main" val="4236878231"/>
+      </p:ext>
+    </p:extLst>
+  </p:cSld>
+  <p:clrMapOvr>
+    <a:masterClrMapping/>
+  </p:clrMapOvr>
+</p:sld>
+</file>
+
+<file path=ppt/slides/slide7.xml><?xml version="1.0" encoding="utf-8"?>
+<p:sld xmlns:a="http://schemas.openxmlformats.org/drawingml/2006/main" xmlns:r="http://schemas.openxmlformats.org/officeDocument/2006/relationships" xmlns:p="http://schemas.openxmlformats.org/presentationml/2006/main">
+  <p:cSld>
+    <p:spTree>
+      <p:nvGrpSpPr>
+        <p:cNvPr id="1" name="">
+          <a:extLst>
+            <a:ext uri="{FF2B5EF4-FFF2-40B4-BE49-F238E27FC236}">
+              <a16:creationId xmlns:a16="http://schemas.microsoft.com/office/drawing/2014/main" id="{FD016826-D9E4-DB7D-8294-07CE667D037C}"/>
+            </a:ext>
+          </a:extLst>
+        </p:cNvPr>
+        <p:cNvGrpSpPr/>
+        <p:nvPr/>
+      </p:nvGrpSpPr>
+      <p:grpSpPr>
+        <a:xfrm>
+          <a:off x="0" y="0"/>
+          <a:ext cx="0" cy="0"/>
+          <a:chOff x="0" y="0"/>
+          <a:chExt cx="0" cy="0"/>
+        </a:xfrm>
+      </p:grpSpPr>
+      <p:sp>
+        <p:nvSpPr>
+          <p:cNvPr id="5" name="Rectangle 4">
+            <a:extLst>
+              <a:ext uri="{FF2B5EF4-FFF2-40B4-BE49-F238E27FC236}">
+                <a16:creationId xmlns:a16="http://schemas.microsoft.com/office/drawing/2014/main" id="{55051011-0C6C-9552-4DAF-AF239A478906}"/>
+              </a:ext>
+            </a:extLst>
+          </p:cNvPr>
+          <p:cNvSpPr/>
+          <p:nvPr/>
+        </p:nvSpPr>
+        <p:spPr>
+          <a:xfrm>
+            <a:off x="2103120" y="1623060"/>
+            <a:ext cx="1811655" cy="1805940"/>
+          </a:xfrm>
+          <a:prstGeom prst="rect">
+            <a:avLst/>
+          </a:prstGeom>
+          <a:solidFill>
+            <a:schemeClr val="tx1"/>
+          </a:solidFill>
+          <a:ln>
+            <a:solidFill>
+              <a:schemeClr val="tx1"/>
+            </a:solidFill>
+          </a:ln>
+        </p:spPr>
+        <p:style>
+          <a:lnRef idx="2">
+            <a:schemeClr val="accent1">
+              <a:shade val="15000"/>
+            </a:schemeClr>
+          </a:lnRef>
+          <a:fillRef idx="1">
+            <a:schemeClr val="accent1"/>
+          </a:fillRef>
+          <a:effectRef idx="0">
+            <a:schemeClr val="accent1"/>
+          </a:effectRef>
+          <a:fontRef idx="minor">
+            <a:schemeClr val="lt1"/>
+          </a:fontRef>
+        </p:style>
+        <p:txBody>
+          <a:bodyPr rtlCol="0" anchor="ctr"/>
+          <a:lstStyle/>
+          <a:p>
+            <a:pPr algn="ctr"/>
+            <a:r>
+              <a:rPr lang="en-US" sz="10800" b="1" dirty="0">
+                <a:latin typeface="Arial" panose="020B0604020202020204" pitchFamily="34" charset="0"/>
+                <a:ea typeface="Apple Color Emoji" pitchFamily="2" charset="0"/>
+                <a:cs typeface="Arial" panose="020B0604020202020204" pitchFamily="34" charset="0"/>
+              </a:rPr>
+              <a:t>++</a:t>
+            </a:r>
+          </a:p>
+        </p:txBody>
+      </p:sp>
+      <p:sp>
+        <p:nvSpPr>
+          <p:cNvPr id="2" name="Rectangle 1">
+            <a:extLst>
+              <a:ext uri="{FF2B5EF4-FFF2-40B4-BE49-F238E27FC236}">
+                <a16:creationId xmlns:a16="http://schemas.microsoft.com/office/drawing/2014/main" id="{3282BB77-F321-DCAD-9303-0C70D1FC2BBD}"/>
+              </a:ext>
+            </a:extLst>
+          </p:cNvPr>
+          <p:cNvSpPr/>
+          <p:nvPr/>
+        </p:nvSpPr>
+        <p:spPr>
+          <a:xfrm>
+            <a:off x="2232636" y="2072368"/>
+            <a:ext cx="1552621" cy="371475"/>
+          </a:xfrm>
+          <a:prstGeom prst="rect">
+            <a:avLst/>
+          </a:prstGeom>
+          <a:solidFill>
+            <a:schemeClr val="tx1"/>
+          </a:solidFill>
+          <a:ln>
+            <a:solidFill>
+              <a:schemeClr val="tx1"/>
+            </a:solidFill>
+          </a:ln>
+        </p:spPr>
+        <p:style>
+          <a:lnRef idx="2">
+            <a:schemeClr val="accent1">
+              <a:shade val="15000"/>
+            </a:schemeClr>
+          </a:lnRef>
+          <a:fillRef idx="1">
+            <a:schemeClr val="accent1"/>
+          </a:fillRef>
+          <a:effectRef idx="0">
+            <a:schemeClr val="accent1"/>
+          </a:effectRef>
+          <a:fontRef idx="minor">
+            <a:schemeClr val="lt1"/>
+          </a:fontRef>
+        </p:style>
+        <p:txBody>
+          <a:bodyPr rtlCol="0" anchor="ctr"/>
+          <a:lstStyle/>
+          <a:p>
+            <a:pPr algn="ctr"/>
+            <a:endParaRPr lang="en-US"/>
+          </a:p>
+        </p:txBody>
+      </p:sp>
+      <p:sp>
+        <p:nvSpPr>
+          <p:cNvPr id="4" name="Rectangle 3">
+            <a:extLst>
+              <a:ext uri="{FF2B5EF4-FFF2-40B4-BE49-F238E27FC236}">
+                <a16:creationId xmlns:a16="http://schemas.microsoft.com/office/drawing/2014/main" id="{6004E19C-0D05-A7DB-753C-2E64CEBD52B1}"/>
+              </a:ext>
+            </a:extLst>
+          </p:cNvPr>
+          <p:cNvSpPr/>
+          <p:nvPr/>
+        </p:nvSpPr>
+        <p:spPr>
+          <a:xfrm>
+            <a:off x="2232636" y="2626405"/>
+            <a:ext cx="1518557" cy="371475"/>
+          </a:xfrm>
+          <a:prstGeom prst="rect">
+            <a:avLst/>
+          </a:prstGeom>
+          <a:solidFill>
+            <a:schemeClr val="tx1"/>
+          </a:solidFill>
+          <a:ln>
+            <a:solidFill>
+              <a:schemeClr val="tx1"/>
+            </a:solidFill>
+          </a:ln>
+        </p:spPr>
+        <p:style>
+          <a:lnRef idx="2">
+            <a:schemeClr val="accent1">
+              <a:shade val="15000"/>
+            </a:schemeClr>
+          </a:lnRef>
+          <a:fillRef idx="1">
+            <a:schemeClr val="accent1"/>
+          </a:fillRef>
+          <a:effectRef idx="0">
+            <a:schemeClr val="accent1"/>
+          </a:effectRef>
+          <a:fontRef idx="minor">
+            <a:schemeClr val="lt1"/>
+          </a:fontRef>
+        </p:style>
+        <p:txBody>
+          <a:bodyPr rtlCol="0" anchor="ctr"/>
+          <a:lstStyle/>
+          <a:p>
+            <a:pPr algn="ctr"/>
+            <a:endParaRPr lang="en-US"/>
+          </a:p>
+        </p:txBody>
+      </p:sp>
+      <p:sp>
+        <p:nvSpPr>
+          <p:cNvPr id="6" name="Rectangle 5">
+            <a:extLst>
+              <a:ext uri="{FF2B5EF4-FFF2-40B4-BE49-F238E27FC236}">
+                <a16:creationId xmlns:a16="http://schemas.microsoft.com/office/drawing/2014/main" id="{7D2B5616-1D56-473B-F587-D99DA739248E}"/>
+              </a:ext>
+            </a:extLst>
+          </p:cNvPr>
+          <p:cNvSpPr/>
+          <p:nvPr/>
+        </p:nvSpPr>
+        <p:spPr>
+          <a:xfrm>
+            <a:off x="2188186" y="2085068"/>
+            <a:ext cx="1552621" cy="371475"/>
+          </a:xfrm>
+          <a:prstGeom prst="rect">
+            <a:avLst/>
+          </a:prstGeom>
+          <a:solidFill>
+            <a:schemeClr val="tx1"/>
+          </a:solidFill>
+          <a:ln>
+            <a:solidFill>
+              <a:schemeClr val="tx1"/>
+            </a:solidFill>
+          </a:ln>
+        </p:spPr>
+        <p:style>
+          <a:lnRef idx="2">
+            <a:schemeClr val="accent1">
+              <a:shade val="15000"/>
+            </a:schemeClr>
+          </a:lnRef>
+          <a:fillRef idx="1">
+            <a:schemeClr val="accent1"/>
+          </a:fillRef>
+          <a:effectRef idx="0">
+            <a:schemeClr val="accent1"/>
+          </a:effectRef>
+          <a:fontRef idx="minor">
+            <a:schemeClr val="lt1"/>
+          </a:fontRef>
+        </p:style>
+        <p:txBody>
+          <a:bodyPr rtlCol="0" anchor="ctr"/>
+          <a:lstStyle/>
+          <a:p>
+            <a:pPr algn="ctr"/>
+            <a:endParaRPr lang="en-US"/>
+          </a:p>
+        </p:txBody>
+      </p:sp>
+      <p:sp>
+        <p:nvSpPr>
+          <p:cNvPr id="7" name="Rectangle 6">
+            <a:extLst>
+              <a:ext uri="{FF2B5EF4-FFF2-40B4-BE49-F238E27FC236}">
+                <a16:creationId xmlns:a16="http://schemas.microsoft.com/office/drawing/2014/main" id="{FCACE5CF-1CC0-2D2E-D7B3-ABAABEAD796A}"/>
+              </a:ext>
+            </a:extLst>
+          </p:cNvPr>
+          <p:cNvSpPr/>
+          <p:nvPr/>
+        </p:nvSpPr>
+        <p:spPr>
+          <a:xfrm>
+            <a:off x="2232636" y="2616880"/>
+            <a:ext cx="1518557" cy="371475"/>
+          </a:xfrm>
+          <a:prstGeom prst="rect">
+            <a:avLst/>
+          </a:prstGeom>
+          <a:solidFill>
+            <a:schemeClr val="tx1"/>
+          </a:solidFill>
+          <a:ln>
+            <a:solidFill>
+              <a:schemeClr val="tx1"/>
+            </a:solidFill>
+          </a:ln>
+        </p:spPr>
+        <p:style>
+          <a:lnRef idx="2">
+            <a:schemeClr val="accent1">
+              <a:shade val="15000"/>
+            </a:schemeClr>
+          </a:lnRef>
+          <a:fillRef idx="1">
+            <a:schemeClr val="accent1"/>
+          </a:fillRef>
+          <a:effectRef idx="0">
+            <a:schemeClr val="accent1"/>
+          </a:effectRef>
+          <a:fontRef idx="minor">
+            <a:schemeClr val="lt1"/>
+          </a:fontRef>
+        </p:style>
+        <p:txBody>
+          <a:bodyPr rtlCol="0" anchor="ctr"/>
+          <a:lstStyle/>
+          <a:p>
+            <a:pPr algn="ctr"/>
+            <a:endParaRPr lang="en-US"/>
+          </a:p>
+        </p:txBody>
+      </p:sp>
+    </p:spTree>
+    <p:extLst>
+      <p:ext uri="{BB962C8B-B14F-4D97-AF65-F5344CB8AC3E}">
+        <p14:creationId xmlns:p14="http://schemas.microsoft.com/office/powerpoint/2010/main" val="1729412280"/>
+      </p:ext>
+    </p:extLst>
+  </p:cSld>
+  <p:clrMapOvr>
+    <a:masterClrMapping/>
+  </p:clrMapOvr>
+</p:sld>
+</file>
+
+<file path=ppt/slides/slide8.xml><?xml version="1.0" encoding="utf-8"?>
+<p:sld xmlns:a="http://schemas.openxmlformats.org/drawingml/2006/main" xmlns:r="http://schemas.openxmlformats.org/officeDocument/2006/relationships" xmlns:p="http://schemas.openxmlformats.org/presentationml/2006/main">
+  <p:cSld>
+    <p:spTree>
+      <p:nvGrpSpPr>
+        <p:cNvPr id="1" name="">
+          <a:extLst>
+            <a:ext uri="{FF2B5EF4-FFF2-40B4-BE49-F238E27FC236}">
+              <a16:creationId xmlns:a16="http://schemas.microsoft.com/office/drawing/2014/main" id="{B002F972-2857-F671-2C06-408E8F3B79B9}"/>
+            </a:ext>
+          </a:extLst>
+        </p:cNvPr>
+        <p:cNvGrpSpPr/>
+        <p:nvPr/>
+      </p:nvGrpSpPr>
+      <p:grpSpPr>
+        <a:xfrm>
+          <a:off x="0" y="0"/>
+          <a:ext cx="0" cy="0"/>
+          <a:chOff x="0" y="0"/>
+          <a:chExt cx="0" cy="0"/>
+        </a:xfrm>
+      </p:grpSpPr>
+      <p:sp>
+        <p:nvSpPr>
+          <p:cNvPr id="5" name="Rectangle 4">
+            <a:extLst>
+              <a:ext uri="{FF2B5EF4-FFF2-40B4-BE49-F238E27FC236}">
+                <a16:creationId xmlns:a16="http://schemas.microsoft.com/office/drawing/2014/main" id="{41703122-64D2-E9FE-4CEF-14F774F0F380}"/>
+              </a:ext>
+            </a:extLst>
+          </p:cNvPr>
+          <p:cNvSpPr/>
+          <p:nvPr/>
+        </p:nvSpPr>
+        <p:spPr>
+          <a:xfrm>
+            <a:off x="2103120" y="1623060"/>
+            <a:ext cx="1811655" cy="1805940"/>
+          </a:xfrm>
+          <a:prstGeom prst="rect">
+            <a:avLst/>
+          </a:prstGeom>
+          <a:solidFill>
+            <a:schemeClr val="tx1"/>
+          </a:solidFill>
+          <a:ln>
+            <a:solidFill>
+              <a:schemeClr val="tx1"/>
+            </a:solidFill>
+          </a:ln>
+        </p:spPr>
+        <p:style>
+          <a:lnRef idx="2">
+            <a:schemeClr val="accent1">
+              <a:shade val="15000"/>
+            </a:schemeClr>
+          </a:lnRef>
+          <a:fillRef idx="1">
+            <a:schemeClr val="accent1"/>
+          </a:fillRef>
+          <a:effectRef idx="0">
+            <a:schemeClr val="accent1"/>
+          </a:effectRef>
+          <a:fontRef idx="minor">
+            <a:schemeClr val="lt1"/>
+          </a:fontRef>
+        </p:style>
+        <p:txBody>
+          <a:bodyPr rtlCol="0" anchor="ctr"/>
+          <a:lstStyle/>
+          <a:p>
+            <a:pPr algn="ctr"/>
+            <a:r>
+              <a:rPr lang="en-US" sz="10800" b="1" dirty="0">
+                <a:latin typeface="Arial" panose="020B0604020202020204" pitchFamily="34" charset="0"/>
+                <a:ea typeface="Apple Color Emoji" pitchFamily="2" charset="0"/>
+                <a:cs typeface="Arial" panose="020B0604020202020204" pitchFamily="34" charset="0"/>
+              </a:rPr>
+              <a:t>+</a:t>
+            </a:r>
+          </a:p>
+        </p:txBody>
+      </p:sp>
+      <p:sp>
+        <p:nvSpPr>
+          <p:cNvPr id="2" name="Rectangle 1">
+            <a:extLst>
+              <a:ext uri="{FF2B5EF4-FFF2-40B4-BE49-F238E27FC236}">
+                <a16:creationId xmlns:a16="http://schemas.microsoft.com/office/drawing/2014/main" id="{E5BD0FA0-1C8C-D01D-090D-3B64C0401BC4}"/>
+              </a:ext>
+            </a:extLst>
+          </p:cNvPr>
+          <p:cNvSpPr/>
+          <p:nvPr/>
+        </p:nvSpPr>
+        <p:spPr>
+          <a:xfrm>
+            <a:off x="2232636" y="2072368"/>
+            <a:ext cx="1552621" cy="371475"/>
+          </a:xfrm>
+          <a:prstGeom prst="rect">
+            <a:avLst/>
+          </a:prstGeom>
+          <a:solidFill>
+            <a:schemeClr val="tx1"/>
+          </a:solidFill>
+          <a:ln>
+            <a:solidFill>
+              <a:schemeClr val="tx1"/>
+            </a:solidFill>
+          </a:ln>
+        </p:spPr>
+        <p:style>
+          <a:lnRef idx="2">
+            <a:schemeClr val="accent1">
+              <a:shade val="15000"/>
+            </a:schemeClr>
+          </a:lnRef>
+          <a:fillRef idx="1">
+            <a:schemeClr val="accent1"/>
+          </a:fillRef>
+          <a:effectRef idx="0">
+            <a:schemeClr val="accent1"/>
+          </a:effectRef>
+          <a:fontRef idx="minor">
+            <a:schemeClr val="lt1"/>
+          </a:fontRef>
+        </p:style>
+        <p:txBody>
+          <a:bodyPr rtlCol="0" anchor="ctr"/>
+          <a:lstStyle/>
+          <a:p>
+            <a:pPr algn="ctr"/>
+            <a:endParaRPr lang="en-US"/>
+          </a:p>
+        </p:txBody>
+      </p:sp>
+      <p:sp>
+        <p:nvSpPr>
+          <p:cNvPr id="4" name="Rectangle 3">
+            <a:extLst>
+              <a:ext uri="{FF2B5EF4-FFF2-40B4-BE49-F238E27FC236}">
+                <a16:creationId xmlns:a16="http://schemas.microsoft.com/office/drawing/2014/main" id="{99297F44-B9BF-93CE-4A65-ED1E81E3F265}"/>
+              </a:ext>
+            </a:extLst>
+          </p:cNvPr>
+          <p:cNvSpPr/>
+          <p:nvPr/>
+        </p:nvSpPr>
+        <p:spPr>
+          <a:xfrm>
+            <a:off x="2232636" y="2626405"/>
+            <a:ext cx="1518557" cy="371475"/>
+          </a:xfrm>
+          <a:prstGeom prst="rect">
+            <a:avLst/>
+          </a:prstGeom>
+          <a:solidFill>
+            <a:schemeClr val="tx1"/>
+          </a:solidFill>
+          <a:ln>
+            <a:solidFill>
+              <a:schemeClr val="tx1"/>
+            </a:solidFill>
+          </a:ln>
+        </p:spPr>
+        <p:style>
+          <a:lnRef idx="2">
+            <a:schemeClr val="accent1">
+              <a:shade val="15000"/>
+            </a:schemeClr>
+          </a:lnRef>
+          <a:fillRef idx="1">
+            <a:schemeClr val="accent1"/>
+          </a:fillRef>
+          <a:effectRef idx="0">
+            <a:schemeClr val="accent1"/>
+          </a:effectRef>
+          <a:fontRef idx="minor">
+            <a:schemeClr val="lt1"/>
+          </a:fontRef>
+        </p:style>
+        <p:txBody>
+          <a:bodyPr rtlCol="0" anchor="ctr"/>
+          <a:lstStyle/>
+          <a:p>
+            <a:pPr algn="ctr"/>
+            <a:endParaRPr lang="en-US"/>
+          </a:p>
+        </p:txBody>
+      </p:sp>
+      <p:sp>
+        <p:nvSpPr>
+          <p:cNvPr id="6" name="Rectangle 5">
+            <a:extLst>
+              <a:ext uri="{FF2B5EF4-FFF2-40B4-BE49-F238E27FC236}">
+                <a16:creationId xmlns:a16="http://schemas.microsoft.com/office/drawing/2014/main" id="{38DDA773-B57D-DD83-5B10-6C7AECB2308D}"/>
+              </a:ext>
+            </a:extLst>
+          </p:cNvPr>
+          <p:cNvSpPr/>
+          <p:nvPr/>
+        </p:nvSpPr>
+        <p:spPr>
+          <a:xfrm>
+            <a:off x="2188186" y="2085068"/>
+            <a:ext cx="1552621" cy="371475"/>
+          </a:xfrm>
+          <a:prstGeom prst="rect">
+            <a:avLst/>
+          </a:prstGeom>
+          <a:solidFill>
+            <a:schemeClr val="tx1"/>
+          </a:solidFill>
+          <a:ln>
+            <a:solidFill>
+              <a:schemeClr val="tx1"/>
+            </a:solidFill>
+          </a:ln>
+        </p:spPr>
+        <p:style>
+          <a:lnRef idx="2">
+            <a:schemeClr val="accent1">
+              <a:shade val="15000"/>
+            </a:schemeClr>
+          </a:lnRef>
+          <a:fillRef idx="1">
+            <a:schemeClr val="accent1"/>
+          </a:fillRef>
+          <a:effectRef idx="0">
+            <a:schemeClr val="accent1"/>
+          </a:effectRef>
+          <a:fontRef idx="minor">
+            <a:schemeClr val="lt1"/>
+          </a:fontRef>
+        </p:style>
+        <p:txBody>
+          <a:bodyPr rtlCol="0" anchor="ctr"/>
+          <a:lstStyle/>
+          <a:p>
+            <a:pPr algn="ctr"/>
+            <a:endParaRPr lang="en-US"/>
+          </a:p>
+        </p:txBody>
+      </p:sp>
+      <p:sp>
+        <p:nvSpPr>
+          <p:cNvPr id="7" name="Rectangle 6">
+            <a:extLst>
+              <a:ext uri="{FF2B5EF4-FFF2-40B4-BE49-F238E27FC236}">
+                <a16:creationId xmlns:a16="http://schemas.microsoft.com/office/drawing/2014/main" id="{F39E3AAB-54CB-E464-BCC4-0D7C6626F8BD}"/>
+              </a:ext>
+            </a:extLst>
+          </p:cNvPr>
+          <p:cNvSpPr/>
+          <p:nvPr/>
+        </p:nvSpPr>
+        <p:spPr>
+          <a:xfrm>
+            <a:off x="2232636" y="2616880"/>
+            <a:ext cx="1518557" cy="371475"/>
+          </a:xfrm>
+          <a:prstGeom prst="rect">
+            <a:avLst/>
+          </a:prstGeom>
+          <a:solidFill>
+            <a:schemeClr val="tx1"/>
+          </a:solidFill>
+          <a:ln>
+            <a:solidFill>
+              <a:schemeClr val="tx1"/>
+            </a:solidFill>
+          </a:ln>
+        </p:spPr>
+        <p:style>
+          <a:lnRef idx="2">
+            <a:schemeClr val="accent1">
+              <a:shade val="15000"/>
+            </a:schemeClr>
+          </a:lnRef>
+          <a:fillRef idx="1">
+            <a:schemeClr val="accent1"/>
+          </a:fillRef>
+          <a:effectRef idx="0">
+            <a:schemeClr val="accent1"/>
+          </a:effectRef>
+          <a:fontRef idx="minor">
+            <a:schemeClr val="lt1"/>
+          </a:fontRef>
+        </p:style>
+        <p:txBody>
+          <a:bodyPr rtlCol="0" anchor="ctr"/>
+          <a:lstStyle/>
+          <a:p>
+            <a:pPr algn="ctr"/>
+            <a:endParaRPr lang="en-US"/>
+          </a:p>
+        </p:txBody>
+      </p:sp>
+    </p:spTree>
+    <p:extLst>
+      <p:ext uri="{BB962C8B-B14F-4D97-AF65-F5344CB8AC3E}">
+        <p14:creationId xmlns:p14="http://schemas.microsoft.com/office/powerpoint/2010/main" val="3682527975"/>
+      </p:ext>
+    </p:extLst>
+  </p:cSld>
+  <p:clrMapOvr>
+    <a:masterClrMapping/>
+  </p:clrMapOvr>
+</p:sld>
+</file>
+
 <file path=ppt/theme/theme1.xml><?xml version="1.0" encoding="utf-8"?>
 <a:theme xmlns:a="http://schemas.openxmlformats.org/drawingml/2006/main" name="Office Theme">
   <a:themeElements>

</xml_diff>